<commit_message>
Record verified Render release and reuse backend for Netlify deployment
</commit_message>
<xml_diff>
--- a/artifacts/deliverables/BizPlus AI Pitch Final.pptx
+++ b/artifacts/deliverables/BizPlus AI Pitch Final.pptx
@@ -2,19 +2,19 @@
 <file path=ppt/presentation.xml><?xml version="1.0" encoding="utf-8"?>
 <p:presentation xmlns:p="http://schemas.openxmlformats.org/presentationml/2006/main">
   <p:sldMasterIdLst>
-    <p:sldMasterId xmlns:r="http://schemas.openxmlformats.org/officeDocument/2006/relationships" id="2147483648" r:id="R6bb45bee052c49f0"/>
+    <p:sldMasterId xmlns:r="http://schemas.openxmlformats.org/officeDocument/2006/relationships" id="2147483648" r:id="R5c45fbf80b334355"/>
   </p:sldMasterIdLst>
   <p:notesMasterIdLst>
-    <p:notesMasterId xmlns:r="http://schemas.openxmlformats.org/officeDocument/2006/relationships" r:id="R3f48f8697c474873"/>
+    <p:notesMasterId xmlns:r="http://schemas.openxmlformats.org/officeDocument/2006/relationships" r:id="R0923858145c1433a"/>
   </p:notesMasterIdLst>
   <p:sldIdLst>
-    <p:sldId xmlns:r="http://schemas.openxmlformats.org/officeDocument/2006/relationships" id="256" r:id="R9b55455ad9e24942"/>
-    <p:sldId xmlns:r="http://schemas.openxmlformats.org/officeDocument/2006/relationships" id="257" r:id="R8a781e6042874c6b"/>
-    <p:sldId xmlns:r="http://schemas.openxmlformats.org/officeDocument/2006/relationships" id="258" r:id="R560b7ec95b634c61"/>
-    <p:sldId xmlns:r="http://schemas.openxmlformats.org/officeDocument/2006/relationships" id="259" r:id="Reab706d12d14445b"/>
-    <p:sldId xmlns:r="http://schemas.openxmlformats.org/officeDocument/2006/relationships" id="260" r:id="Rbfcff7a16ba1438c"/>
-    <p:sldId xmlns:r="http://schemas.openxmlformats.org/officeDocument/2006/relationships" id="261" r:id="Rbcfca5b67f9a4e5a"/>
-    <p:sldId xmlns:r="http://schemas.openxmlformats.org/officeDocument/2006/relationships" id="262" r:id="Rc71795bcb4674a66"/>
+    <p:sldId xmlns:r="http://schemas.openxmlformats.org/officeDocument/2006/relationships" id="256" r:id="R429174ccc42f4983"/>
+    <p:sldId xmlns:r="http://schemas.openxmlformats.org/officeDocument/2006/relationships" id="257" r:id="R8736e428b420463a"/>
+    <p:sldId xmlns:r="http://schemas.openxmlformats.org/officeDocument/2006/relationships" id="258" r:id="R07d596073c724e4d"/>
+    <p:sldId xmlns:r="http://schemas.openxmlformats.org/officeDocument/2006/relationships" id="259" r:id="R2970eeb5c956481f"/>
+    <p:sldId xmlns:r="http://schemas.openxmlformats.org/officeDocument/2006/relationships" id="260" r:id="R4cc098baaeb243c1"/>
+    <p:sldId xmlns:r="http://schemas.openxmlformats.org/officeDocument/2006/relationships" id="261" r:id="Reb4339018b224c68"/>
+    <p:sldId xmlns:r="http://schemas.openxmlformats.org/officeDocument/2006/relationships" id="262" r:id="Re8b30f8bd3574e66"/>
   </p:sldIdLst>
   <p:sldSz cx="12192000" cy="6858000"/>
   <p:notesSz cx="6858000" cy="9144000"/>
@@ -868,7 +868,7 @@
           <a:lstStyle xmlns:a="http://schemas.openxmlformats.org/drawingml/2006/main"/>
           <a:p xmlns:a="http://schemas.openxmlformats.org/drawingml/2006/main">
             <a:r>
-              <a:t>Current release status: Local API and browser journey verified. Public deployment and cold-start checks remain pending.. Public demo: Not yet deployed. Repository: https://github.com/Emadfar007/bizplus-ai. Do not describe local verification as public deployment. Priorities are production authentication and an action audit policy, durable shared storage, then evaluated optional LLM summaries and additional owned journeys. Keep a local tested fallback for free-host cold starts. Hosting references: https://render.com/docs/free and https://docs.netlify.com/build/frameworks/framework-setup-guides/vite/ .</a:t>
+              <a:t>Current release status: Local browser journey verified. Render backend deployed and 18/18 public HTTP smoke checks passed. Netlify dashboard deployment, public browser acceptance, hosted cold-start and second-device checks remain pending.. Backend: https://bizplus-ai-api.onrender.com. Public dashboard: Not yet deployed. Repository: https://github.com/Emadfar007/bizplus-ai. Local sandbox measurements on slide 6 remain from the local replay, not the hosted replay. Priorities are production authentication and an action audit policy, durable shared storage, then evaluated optional LLM summaries and additional owned journeys. Keep a local tested fallback for free-host cold starts. Hosting references: https://render.com/docs/free and https://docs.netlify.com/build/frameworks/framework-setup-guides/vite/ .</a:t>
             </a:r>
           </a:p>
         </p:txBody>
@@ -915,7 +915,7 @@
           <p:cNvPr id="3" name="Title">
             <a:extLst xmlns:a="http://schemas.openxmlformats.org/drawingml/2006/main">
               <a:ext uri="{FF2B5EF4-FFF2-40B4-BE49-F238E27FC236}">
-                <a16:creationId xmlns:a16="http://schemas.microsoft.com/office/drawing/2014/main" id="{201300FF-BE36-4FB8-8862-C606DE141DBF}"/>
+                <a16:creationId xmlns:a16="http://schemas.microsoft.com/office/drawing/2014/main" id="{9903EB77-A65D-45A0-A7EE-FDDBCB7CC802}"/>
               </a:ext>
             </a:extLst>
           </p:cNvPr>
@@ -1072,7 +1072,7 @@
           <p:cNvPr id="2" name="Subtitle">
             <a:extLst xmlns:a="http://schemas.openxmlformats.org/drawingml/2006/main">
               <a:ext uri="{FF2B5EF4-FFF2-40B4-BE49-F238E27FC236}">
-                <a16:creationId xmlns:a16="http://schemas.microsoft.com/office/drawing/2014/main" id="{02AA8281-0540-4218-9993-0015D0CC1EFC}"/>
+                <a16:creationId xmlns:a16="http://schemas.microsoft.com/office/drawing/2014/main" id="{9E3B656E-48A3-42EF-A2CF-00829347FF3E}"/>
               </a:ext>
             </a:extLst>
           </p:cNvPr>
@@ -1246,7 +1246,7 @@
           <p:cNvPr id="2" name="Section title">
             <a:extLst xmlns:a="http://schemas.openxmlformats.org/drawingml/2006/main">
               <a:ext uri="{FF2B5EF4-FFF2-40B4-BE49-F238E27FC236}">
-                <a16:creationId xmlns:a16="http://schemas.microsoft.com/office/drawing/2014/main" id="{405D1E08-B44B-4F66-A963-BFE6DF8D393F}"/>
+                <a16:creationId xmlns:a16="http://schemas.microsoft.com/office/drawing/2014/main" id="{90E6EE42-10E1-44F5-9655-865CD5050281}"/>
               </a:ext>
             </a:extLst>
           </p:cNvPr>
@@ -1420,7 +1420,7 @@
           <p:cNvPr id="3" name="Title">
             <a:extLst xmlns:a="http://schemas.openxmlformats.org/drawingml/2006/main">
               <a:ext uri="{FF2B5EF4-FFF2-40B4-BE49-F238E27FC236}">
-                <a16:creationId xmlns:a16="http://schemas.microsoft.com/office/drawing/2014/main" id="{0774D8AF-F3D1-4177-AECA-92865F813672}"/>
+                <a16:creationId xmlns:a16="http://schemas.microsoft.com/office/drawing/2014/main" id="{402A0095-E093-416E-A1B3-BF4F1DC2B58C}"/>
               </a:ext>
             </a:extLst>
           </p:cNvPr>
@@ -1577,7 +1577,7 @@
           <p:cNvPr id="2" name="Body">
             <a:extLst xmlns:a="http://schemas.openxmlformats.org/drawingml/2006/main">
               <a:ext uri="{FF2B5EF4-FFF2-40B4-BE49-F238E27FC236}">
-                <a16:creationId xmlns:a16="http://schemas.microsoft.com/office/drawing/2014/main" id="{08523920-DAB0-4E44-AB59-257E048F4EA5}"/>
+                <a16:creationId xmlns:a16="http://schemas.microsoft.com/office/drawing/2014/main" id="{36666C5C-05CA-4E14-B8B3-736B9A3F8F77}"/>
               </a:ext>
             </a:extLst>
           </p:cNvPr>
@@ -1751,7 +1751,7 @@
           <p:cNvPr id="4" name="Title">
             <a:extLst xmlns:a="http://schemas.openxmlformats.org/drawingml/2006/main">
               <a:ext uri="{FF2B5EF4-FFF2-40B4-BE49-F238E27FC236}">
-                <a16:creationId xmlns:a16="http://schemas.microsoft.com/office/drawing/2014/main" id="{1D2A5FFE-8FF7-4FC4-A7F5-A7EE73081C4F}"/>
+                <a16:creationId xmlns:a16="http://schemas.microsoft.com/office/drawing/2014/main" id="{FB50A635-7AE2-4F13-99B3-D41AB04F2EE1}"/>
               </a:ext>
             </a:extLst>
           </p:cNvPr>
@@ -1908,7 +1908,7 @@
           <p:cNvPr id="2" name="Left column">
             <a:extLst xmlns:a="http://schemas.openxmlformats.org/drawingml/2006/main">
               <a:ext uri="{FF2B5EF4-FFF2-40B4-BE49-F238E27FC236}">
-                <a16:creationId xmlns:a16="http://schemas.microsoft.com/office/drawing/2014/main" id="{9BA83241-D535-4C7E-B7E3-22761920226A}"/>
+                <a16:creationId xmlns:a16="http://schemas.microsoft.com/office/drawing/2014/main" id="{44AFADEB-5ECC-4491-B321-AECEB30FAA25}"/>
               </a:ext>
             </a:extLst>
           </p:cNvPr>
@@ -2065,7 +2065,7 @@
           <p:cNvPr id="3" name="Right column">
             <a:extLst xmlns:a="http://schemas.openxmlformats.org/drawingml/2006/main">
               <a:ext uri="{FF2B5EF4-FFF2-40B4-BE49-F238E27FC236}">
-                <a16:creationId xmlns:a16="http://schemas.microsoft.com/office/drawing/2014/main" id="{2F89D0FD-BC10-4C8F-A15B-79BB7FAA1AAC}"/>
+                <a16:creationId xmlns:a16="http://schemas.microsoft.com/office/drawing/2014/main" id="{D52F0CEF-B098-4145-BB83-3F37DA68ADE5}"/>
               </a:ext>
             </a:extLst>
           </p:cNvPr>
@@ -2239,7 +2239,7 @@
           <p:cNvPr id="3" name="Title">
             <a:extLst xmlns:a="http://schemas.openxmlformats.org/drawingml/2006/main">
               <a:ext uri="{FF2B5EF4-FFF2-40B4-BE49-F238E27FC236}">
-                <a16:creationId xmlns:a16="http://schemas.microsoft.com/office/drawing/2014/main" id="{AD1F53A4-E50D-46EB-AF52-33196AC7E3BD}"/>
+                <a16:creationId xmlns:a16="http://schemas.microsoft.com/office/drawing/2014/main" id="{EB165005-408C-426A-BE22-4D5DC8FED0B7}"/>
               </a:ext>
             </a:extLst>
           </p:cNvPr>
@@ -2396,7 +2396,7 @@
           <p:cNvPr id="2" name="Left column">
             <a:extLst xmlns:a="http://schemas.openxmlformats.org/drawingml/2006/main">
               <a:ext uri="{FF2B5EF4-FFF2-40B4-BE49-F238E27FC236}">
-                <a16:creationId xmlns:a16="http://schemas.microsoft.com/office/drawing/2014/main" id="{AED5C09F-5121-4676-9AAF-2B4C9269CF28}"/>
+                <a16:creationId xmlns:a16="http://schemas.microsoft.com/office/drawing/2014/main" id="{8D3993AA-5D57-4FE9-ADBA-12AED4219206}"/>
               </a:ext>
             </a:extLst>
           </p:cNvPr>
@@ -2591,12 +2591,12 @@
   </p:cSld>
   <p:clrMap bg1="lt1" tx1="dk1" bg2="lt2" tx2="dk2" accent1="accent1" accent2="accent2" accent3="accent3" accent4="accent4" accent5="accent5" accent6="accent6" hlink="hlink" folHlink="folHlink"/>
   <p:sldLayoutIdLst>
-    <p:sldLayoutId xmlns:r="http://schemas.openxmlformats.org/officeDocument/2006/relationships" id="2147483649" r:id="Re48438b743ca4168"/>
-    <p:sldLayoutId xmlns:r="http://schemas.openxmlformats.org/officeDocument/2006/relationships" id="2147483650" r:id="R1381a5ef8b1f48b9"/>
-    <p:sldLayoutId xmlns:r="http://schemas.openxmlformats.org/officeDocument/2006/relationships" id="2147483651" r:id="R80526e77bf004dc8"/>
-    <p:sldLayoutId xmlns:r="http://schemas.openxmlformats.org/officeDocument/2006/relationships" id="2147483652" r:id="Rbc54eb80e61a4e92"/>
-    <p:sldLayoutId xmlns:r="http://schemas.openxmlformats.org/officeDocument/2006/relationships" id="2147483653" r:id="R7fb12d5abe844b0a"/>
-    <p:sldLayoutId xmlns:r="http://schemas.openxmlformats.org/officeDocument/2006/relationships" id="2147483654" r:id="R76a96b9123b042d5"/>
+    <p:sldLayoutId xmlns:r="http://schemas.openxmlformats.org/officeDocument/2006/relationships" id="2147483649" r:id="R297d8623a8aa428e"/>
+    <p:sldLayoutId xmlns:r="http://schemas.openxmlformats.org/officeDocument/2006/relationships" id="2147483650" r:id="R9068c75e8ba44c2d"/>
+    <p:sldLayoutId xmlns:r="http://schemas.openxmlformats.org/officeDocument/2006/relationships" id="2147483651" r:id="Re7b560f27a804cca"/>
+    <p:sldLayoutId xmlns:r="http://schemas.openxmlformats.org/officeDocument/2006/relationships" id="2147483652" r:id="Rb4249609b6014668"/>
+    <p:sldLayoutId xmlns:r="http://schemas.openxmlformats.org/officeDocument/2006/relationships" id="2147483653" r:id="Rb3dc2a97906c499c"/>
+    <p:sldLayoutId xmlns:r="http://schemas.openxmlformats.org/officeDocument/2006/relationships" id="2147483654" r:id="Rd8b8b54438694b09"/>
   </p:sldLayoutIdLst>
   <p:txStyles>
     <p:titleStyle>
@@ -3147,7 +3147,7 @@
           <p:cNvPr id="6" name="BizPlus AI">
             <a:extLst xmlns:a="http://schemas.openxmlformats.org/drawingml/2006/main">
               <a:ext uri="{FF2B5EF4-FFF2-40B4-BE49-F238E27FC236}">
-                <a16:creationId xmlns:a16="http://schemas.microsoft.com/office/drawing/2014/main" id="{369DB83F-49AC-4E8A-8823-6EA5AE6F1192}"/>
+                <a16:creationId xmlns:a16="http://schemas.microsoft.com/office/drawing/2014/main" id="{34F738BF-F742-432A-86EC-AA2D353CB8F8}"/>
               </a:ext>
             </a:extLst>
           </p:cNvPr>
@@ -3215,7 +3215,7 @@
           <p:cNvPr id="2" name="BizPlus AI     1/7">
             <a:extLst xmlns:a="http://schemas.openxmlformats.org/drawingml/2006/main">
               <a:ext uri="{FF2B5EF4-FFF2-40B4-BE49-F238E27FC236}">
-                <a16:creationId xmlns:a16="http://schemas.microsoft.com/office/drawing/2014/main" id="{7EB8AE56-8D42-40A6-8931-18075042631E}"/>
+                <a16:creationId xmlns:a16="http://schemas.microsoft.com/office/drawing/2014/main" id="{EF5677AD-5121-44A2-873F-5C8FB06564AD}"/>
               </a:ext>
             </a:extLst>
           </p:cNvPr>
@@ -3283,7 +3283,7 @@
           <p:cNvPr id="3" name="A successful HTTP response can hide&#10;a missing customer order">
             <a:extLst xmlns:a="http://schemas.openxmlformats.org/drawingml/2006/main">
               <a:ext uri="{FF2B5EF4-FFF2-40B4-BE49-F238E27FC236}">
-                <a16:creationId xmlns:a16="http://schemas.microsoft.com/office/drawing/2014/main" id="{785F5617-0A87-428B-85D1-227E98291B2E}"/>
+                <a16:creationId xmlns:a16="http://schemas.microsoft.com/office/drawing/2014/main" id="{8CB69B21-FBE2-4CFD-B78F-AFB9D2E91FCF}"/>
               </a:ext>
             </a:extLst>
           </p:cNvPr>
@@ -3374,7 +3374,7 @@
           <p:cNvPr id="4" name="Business transaction monitoring and approved recovery">
             <a:extLst xmlns:a="http://schemas.openxmlformats.org/drawingml/2006/main">
               <a:ext uri="{FF2B5EF4-FFF2-40B4-BE49-F238E27FC236}">
-                <a16:creationId xmlns:a16="http://schemas.microsoft.com/office/drawing/2014/main" id="{9804376C-1D90-4D46-9355-B33D793544FB}"/>
+                <a16:creationId xmlns:a16="http://schemas.microsoft.com/office/drawing/2014/main" id="{71BA1D6A-F5CC-4E80-A0EB-72C7BBA715FD}"/>
               </a:ext>
             </a:extLst>
           </p:cNvPr>
@@ -3442,7 +3442,7 @@
           <p:cNvPr id="5" name="The demo checks the outcome, captures evidence,&#10;and verifies the origi">
             <a:extLst xmlns:a="http://schemas.openxmlformats.org/drawingml/2006/main">
               <a:ext uri="{FF2B5EF4-FFF2-40B4-BE49-F238E27FC236}">
-                <a16:creationId xmlns:a16="http://schemas.microsoft.com/office/drawing/2014/main" id="{ECD47E4C-FD4A-405F-B53F-C43BA2B1B3F3}"/>
+                <a16:creationId xmlns:a16="http://schemas.microsoft.com/office/drawing/2014/main" id="{F9CBEB10-B2CD-4265-9576-DDDF6E21AB5A}"/>
               </a:ext>
             </a:extLst>
           </p:cNvPr>
@@ -3531,7 +3531,7 @@
     </p:spTree>
     <p:extLst>
       <p:ext uri="{BB962C8B-B14F-4D97-AF65-F5344CB8AC3E}">
-        <p14:creationId xmlns:p14="http://schemas.microsoft.com/office/powerpoint/2010/main" val="2015698855"/>
+        <p14:creationId xmlns:p14="http://schemas.microsoft.com/office/powerpoint/2010/main" val="1575166472"/>
       </p:ext>
     </p:extLst>
   </p:cSld>
@@ -3562,7 +3562,7 @@
           <p:cNvPr id="6" name="Customer impact of missing confirmation">
             <a:extLst xmlns:a="http://schemas.openxmlformats.org/drawingml/2006/main">
               <a:ext uri="{FF2B5EF4-FFF2-40B4-BE49-F238E27FC236}">
-                <a16:creationId xmlns:a16="http://schemas.microsoft.com/office/drawing/2014/main" id="{E46C77A7-9624-4896-8E4C-905FAAE8F53B}"/>
+                <a16:creationId xmlns:a16="http://schemas.microsoft.com/office/drawing/2014/main" id="{EAF53E70-640E-4970-B589-39122E44E65B}"/>
               </a:ext>
             </a:extLst>
           </p:cNvPr>
@@ -3630,7 +3630,7 @@
           <p:cNvPr id="2" name="BizPlus AI     2/7">
             <a:extLst xmlns:a="http://schemas.openxmlformats.org/drawingml/2006/main">
               <a:ext uri="{FF2B5EF4-FFF2-40B4-BE49-F238E27FC236}">
-                <a16:creationId xmlns:a16="http://schemas.microsoft.com/office/drawing/2014/main" id="{BD8FE5E0-A09A-4B63-A979-91AF54808EAE}"/>
+                <a16:creationId xmlns:a16="http://schemas.microsoft.com/office/drawing/2014/main" id="{A77DBB65-D9E3-47F0-AA48-047C1C861E07}"/>
               </a:ext>
             </a:extLst>
           </p:cNvPr>
@@ -3698,7 +3698,7 @@
           <p:cNvPr id="3" name="">
             <a:extLst xmlns:a="http://schemas.openxmlformats.org/drawingml/2006/main">
               <a:ext uri="{FF2B5EF4-FFF2-40B4-BE49-F238E27FC236}">
-                <a16:creationId xmlns:a16="http://schemas.microsoft.com/office/drawing/2014/main" id="{829D92D4-B53D-4CA1-99C5-D860A55D5B21}"/>
+                <a16:creationId xmlns:a16="http://schemas.microsoft.com/office/drawing/2014/main" id="{74793578-14F4-4F55-9A46-50C55CC1FA71}"/>
               </a:ext>
             </a:extLst>
           </p:cNvPr>
@@ -4058,7 +4058,7 @@
           <p:cNvPr id="4" name="Recovery must preserve the original payment">
             <a:extLst xmlns:a="http://schemas.openxmlformats.org/drawingml/2006/main">
               <a:ext uri="{FF2B5EF4-FFF2-40B4-BE49-F238E27FC236}">
-                <a16:creationId xmlns:a16="http://schemas.microsoft.com/office/drawing/2014/main" id="{CD5744AF-8993-4A37-A719-EBB521BA7744}"/>
+                <a16:creationId xmlns:a16="http://schemas.microsoft.com/office/drawing/2014/main" id="{56099B39-8F88-4F29-8C23-A9BA3BA03B7C}"/>
               </a:ext>
             </a:extLst>
           </p:cNvPr>
@@ -4126,7 +4126,7 @@
           <p:cNvPr id="5" name="A business assertion checks the order and amount, alongside status cod">
             <a:extLst xmlns:a="http://schemas.openxmlformats.org/drawingml/2006/main">
               <a:ext uri="{FF2B5EF4-FFF2-40B4-BE49-F238E27FC236}">
-                <a16:creationId xmlns:a16="http://schemas.microsoft.com/office/drawing/2014/main" id="{FB76FA00-7121-4326-A0BC-B55A89E54DF2}"/>
+                <a16:creationId xmlns:a16="http://schemas.microsoft.com/office/drawing/2014/main" id="{96713473-23BC-49C2-8670-272C0C35406F}"/>
               </a:ext>
             </a:extLst>
           </p:cNvPr>
@@ -4192,7 +4192,7 @@
     </p:spTree>
     <p:extLst>
       <p:ext uri="{BB962C8B-B14F-4D97-AF65-F5344CB8AC3E}">
-        <p14:creationId xmlns:p14="http://schemas.microsoft.com/office/powerpoint/2010/main" val="794051212"/>
+        <p14:creationId xmlns:p14="http://schemas.microsoft.com/office/powerpoint/2010/main" val="653772035"/>
       </p:ext>
     </p:extLst>
   </p:cSld>
@@ -4223,7 +4223,7 @@
           <p:cNvPr id="6" name="Monitoring with visible evidence">
             <a:extLst xmlns:a="http://schemas.openxmlformats.org/drawingml/2006/main">
               <a:ext uri="{FF2B5EF4-FFF2-40B4-BE49-F238E27FC236}">
-                <a16:creationId xmlns:a16="http://schemas.microsoft.com/office/drawing/2014/main" id="{5A72E62B-692D-4601-9894-C3A2F75E56BF}"/>
+                <a16:creationId xmlns:a16="http://schemas.microsoft.com/office/drawing/2014/main" id="{9C64857C-56EC-4AA7-AD6E-F5CD3BE948A3}"/>
               </a:ext>
             </a:extLst>
           </p:cNvPr>
@@ -4291,7 +4291,7 @@
           <p:cNvPr id="2" name="BizPlus AI     3/7">
             <a:extLst xmlns:a="http://schemas.openxmlformats.org/drawingml/2006/main">
               <a:ext uri="{FF2B5EF4-FFF2-40B4-BE49-F238E27FC236}">
-                <a16:creationId xmlns:a16="http://schemas.microsoft.com/office/drawing/2014/main" id="{05989E40-D885-4B07-B4BD-2D3801D2710F}"/>
+                <a16:creationId xmlns:a16="http://schemas.microsoft.com/office/drawing/2014/main" id="{3127CA1F-1FD3-4D50-B23A-801AF1EFB052}"/>
               </a:ext>
             </a:extLst>
           </p:cNvPr>
@@ -4359,7 +4359,7 @@
           <p:cNvPr id="3" name="Run a scenario and inspect its actual HTTP results">
             <a:extLst xmlns:a="http://schemas.openxmlformats.org/drawingml/2006/main">
               <a:ext uri="{FF2B5EF4-FFF2-40B4-BE49-F238E27FC236}">
-                <a16:creationId xmlns:a16="http://schemas.microsoft.com/office/drawing/2014/main" id="{CF9DC71D-FCBF-4180-A38D-181BF20080EC}"/>
+                <a16:creationId xmlns:a16="http://schemas.microsoft.com/office/drawing/2014/main" id="{E5F59C59-97C5-49F4-AD81-0DE7898E3828}"/>
               </a:ext>
             </a:extLst>
           </p:cNvPr>
@@ -4427,7 +4427,7 @@
           <p:cNvPr id="4" name="">
             <a:extLst xmlns:a="http://schemas.openxmlformats.org/drawingml/2006/main">
               <a:ext uri="{FF2B5EF4-FFF2-40B4-BE49-F238E27FC236}">
-                <a16:creationId xmlns:a16="http://schemas.microsoft.com/office/drawing/2014/main" id="{643FD202-D32A-41AD-9B20-B151EF2530C1}"/>
+                <a16:creationId xmlns:a16="http://schemas.microsoft.com/office/drawing/2014/main" id="{71D637C4-DB31-40C5-AD7A-8F6EA2F3181C}"/>
               </a:ext>
             </a:extLst>
           </p:cNvPr>
@@ -4437,7 +4437,7 @@
           <p:nvPr/>
         </p:nvPicPr>
         <p:blipFill>
-          <a:blip xmlns:r="http://schemas.openxmlformats.org/officeDocument/2006/relationships" xmlns:a="http://schemas.openxmlformats.org/drawingml/2006/main" r:embed="R79fdb541c9b34783"/>
+          <a:blip xmlns:r="http://schemas.openxmlformats.org/officeDocument/2006/relationships" xmlns:a="http://schemas.openxmlformats.org/drawingml/2006/main" r:embed="Rd698679109114a12"/>
           <a:srcRect xmlns:a="http://schemas.openxmlformats.org/drawingml/2006/main" l="18300" t="11000" r="3500" b="35500"/>
           <a:stretch xmlns:a="http://schemas.openxmlformats.org/drawingml/2006/main"/>
         </p:blipFill>
@@ -4456,7 +4456,7 @@
           <p:cNvPr id="5" name="Rules-based diagnosis     Synthetic payments     Isolated demo session">
             <a:extLst xmlns:a="http://schemas.openxmlformats.org/drawingml/2006/main">
               <a:ext uri="{FF2B5EF4-FFF2-40B4-BE49-F238E27FC236}">
-                <a16:creationId xmlns:a16="http://schemas.microsoft.com/office/drawing/2014/main" id="{DCD6A82F-3C2A-42BD-837C-05D22EE834F4}"/>
+                <a16:creationId xmlns:a16="http://schemas.microsoft.com/office/drawing/2014/main" id="{91FAEEF0-C520-4A96-B8E8-2D4834868270}"/>
               </a:ext>
             </a:extLst>
           </p:cNvPr>
@@ -4522,7 +4522,7 @@
     </p:spTree>
     <p:extLst>
       <p:ext uri="{BB962C8B-B14F-4D97-AF65-F5344CB8AC3E}">
-        <p14:creationId xmlns:p14="http://schemas.microsoft.com/office/powerpoint/2010/main" val="1582280465"/>
+        <p14:creationId xmlns:p14="http://schemas.microsoft.com/office/powerpoint/2010/main" val="1056808587"/>
       </p:ext>
     </p:extLst>
   </p:cSld>
@@ -4553,7 +4553,7 @@
           <p:cNvPr id="18" name="">
             <a:extLst xmlns:a="http://schemas.openxmlformats.org/drawingml/2006/main">
               <a:ext uri="{FF2B5EF4-FFF2-40B4-BE49-F238E27FC236}">
-                <a16:creationId xmlns:a16="http://schemas.microsoft.com/office/drawing/2014/main" id="{A74BCDFF-63D2-4426-976B-9133ECD37474}"/>
+                <a16:creationId xmlns:a16="http://schemas.microsoft.com/office/drawing/2014/main" id="{A00A14C4-D354-4873-9DB1-26421EC1E962}"/>
               </a:ext>
             </a:extLst>
           </p:cNvPr>
@@ -4584,7 +4584,7 @@
           <p:cNvPr id="17" name="">
             <a:extLst xmlns:a="http://schemas.openxmlformats.org/drawingml/2006/main">
               <a:ext uri="{FF2B5EF4-FFF2-40B4-BE49-F238E27FC236}">
-                <a16:creationId xmlns:a16="http://schemas.microsoft.com/office/drawing/2014/main" id="{01B2B2C4-FA4C-48EE-91AE-E5767F72F1F6}"/>
+                <a16:creationId xmlns:a16="http://schemas.microsoft.com/office/drawing/2014/main" id="{5C635EC3-3E19-4E8C-A870-E3CECAF86A26}"/>
               </a:ext>
             </a:extLst>
           </p:cNvPr>
@@ -4615,7 +4615,7 @@
           <p:cNvPr id="15" name="">
             <a:extLst xmlns:a="http://schemas.openxmlformats.org/drawingml/2006/main">
               <a:ext uri="{FF2B5EF4-FFF2-40B4-BE49-F238E27FC236}">
-                <a16:creationId xmlns:a16="http://schemas.microsoft.com/office/drawing/2014/main" id="{A6338181-F8B5-4841-9E81-B08F046D4629}"/>
+                <a16:creationId xmlns:a16="http://schemas.microsoft.com/office/drawing/2014/main" id="{F1E2E7DF-47B9-4A21-81C8-563E2C8AC3B5}"/>
               </a:ext>
             </a:extLst>
           </p:cNvPr>
@@ -4646,7 +4646,7 @@
           <p:cNvPr id="13" name="">
             <a:extLst xmlns:a="http://schemas.openxmlformats.org/drawingml/2006/main">
               <a:ext uri="{FF2B5EF4-FFF2-40B4-BE49-F238E27FC236}">
-                <a16:creationId xmlns:a16="http://schemas.microsoft.com/office/drawing/2014/main" id="{E2CE582B-BE1D-4735-8EE0-42335C1FB827}"/>
+                <a16:creationId xmlns:a16="http://schemas.microsoft.com/office/drawing/2014/main" id="{1539F419-70ED-41B0-A128-3AA1368C97DE}"/>
               </a:ext>
             </a:extLst>
           </p:cNvPr>
@@ -4677,7 +4677,7 @@
           <p:cNvPr id="11" name="">
             <a:extLst xmlns:a="http://schemas.openxmlformats.org/drawingml/2006/main">
               <a:ext uri="{FF2B5EF4-FFF2-40B4-BE49-F238E27FC236}">
-                <a16:creationId xmlns:a16="http://schemas.microsoft.com/office/drawing/2014/main" id="{4C8A201C-BE36-4CA8-8A1A-224A32478F00}"/>
+                <a16:creationId xmlns:a16="http://schemas.microsoft.com/office/drawing/2014/main" id="{19F2892C-E44A-45AB-9234-49C0436AC06B}"/>
               </a:ext>
             </a:extLst>
           </p:cNvPr>
@@ -4708,7 +4708,7 @@
           <p:cNvPr id="9" name="">
             <a:extLst xmlns:a="http://schemas.openxmlformats.org/drawingml/2006/main">
               <a:ext uri="{FF2B5EF4-FFF2-40B4-BE49-F238E27FC236}">
-                <a16:creationId xmlns:a16="http://schemas.microsoft.com/office/drawing/2014/main" id="{6C5AF793-2610-4A16-9A07-4AD7D5504E7C}"/>
+                <a16:creationId xmlns:a16="http://schemas.microsoft.com/office/drawing/2014/main" id="{5E0290B3-7237-4BC0-81C0-236261564B81}"/>
               </a:ext>
             </a:extLst>
           </p:cNvPr>
@@ -4739,7 +4739,7 @@
           <p:cNvPr id="7" name="">
             <a:extLst xmlns:a="http://schemas.openxmlformats.org/drawingml/2006/main">
               <a:ext uri="{FF2B5EF4-FFF2-40B4-BE49-F238E27FC236}">
-                <a16:creationId xmlns:a16="http://schemas.microsoft.com/office/drawing/2014/main" id="{D5762028-7026-4712-9418-7577EF29AFB4}"/>
+                <a16:creationId xmlns:a16="http://schemas.microsoft.com/office/drawing/2014/main" id="{523B92ED-6B79-4866-9D21-F265108194A6}"/>
               </a:ext>
             </a:extLst>
           </p:cNvPr>
@@ -4770,7 +4770,7 @@
           <p:cNvPr id="6" name="">
             <a:extLst xmlns:a="http://schemas.openxmlformats.org/drawingml/2006/main">
               <a:ext uri="{FF2B5EF4-FFF2-40B4-BE49-F238E27FC236}">
-                <a16:creationId xmlns:a16="http://schemas.microsoft.com/office/drawing/2014/main" id="{19FC5F1D-908C-4CD9-8C7A-17AE28C49429}"/>
+                <a16:creationId xmlns:a16="http://schemas.microsoft.com/office/drawing/2014/main" id="{FADD1365-7B25-4309-A54B-A1EF03DB4F0D}"/>
               </a:ext>
             </a:extLst>
           </p:cNvPr>
@@ -4801,7 +4801,7 @@
           <p:cNvPr id="21" name="Application architecture">
             <a:extLst xmlns:a="http://schemas.openxmlformats.org/drawingml/2006/main">
               <a:ext uri="{FF2B5EF4-FFF2-40B4-BE49-F238E27FC236}">
-                <a16:creationId xmlns:a16="http://schemas.microsoft.com/office/drawing/2014/main" id="{E982FDC1-6B73-44BB-812F-B4895E016857}"/>
+                <a16:creationId xmlns:a16="http://schemas.microsoft.com/office/drawing/2014/main" id="{19CFF738-A3BB-4535-868F-273DEDBE77BC}"/>
               </a:ext>
             </a:extLst>
           </p:cNvPr>
@@ -4869,7 +4869,7 @@
           <p:cNvPr id="2" name="BizPlus AI     4/7">
             <a:extLst xmlns:a="http://schemas.openxmlformats.org/drawingml/2006/main">
               <a:ext uri="{FF2B5EF4-FFF2-40B4-BE49-F238E27FC236}">
-                <a16:creationId xmlns:a16="http://schemas.microsoft.com/office/drawing/2014/main" id="{A091815E-AEFB-477D-BB8D-A926B1A9FFF6}"/>
+                <a16:creationId xmlns:a16="http://schemas.microsoft.com/office/drawing/2014/main" id="{6EEAE2DD-4DF0-4277-B163-2E44DDB572FE}"/>
               </a:ext>
             </a:extLst>
           </p:cNvPr>
@@ -4937,7 +4937,7 @@
           <p:cNvPr id="3" name="Judge browser">
             <a:extLst xmlns:a="http://schemas.openxmlformats.org/drawingml/2006/main">
               <a:ext uri="{FF2B5EF4-FFF2-40B4-BE49-F238E27FC236}">
-                <a16:creationId xmlns:a16="http://schemas.microsoft.com/office/drawing/2014/main" id="{AC73C203-8E3A-4263-BD88-4DD1D6AE3824}"/>
+                <a16:creationId xmlns:a16="http://schemas.microsoft.com/office/drawing/2014/main" id="{F4BE8B5C-1C38-4E84-9A4E-8C628E295F78}"/>
               </a:ext>
             </a:extLst>
           </p:cNvPr>
@@ -5007,7 +5007,7 @@
           <p:cNvPr id="4" name="React on Netlify">
             <a:extLst xmlns:a="http://schemas.openxmlformats.org/drawingml/2006/main">
               <a:ext uri="{FF2B5EF4-FFF2-40B4-BE49-F238E27FC236}">
-                <a16:creationId xmlns:a16="http://schemas.microsoft.com/office/drawing/2014/main" id="{EA4CEE54-D68B-4521-8C11-788EDC2F5F95}"/>
+                <a16:creationId xmlns:a16="http://schemas.microsoft.com/office/drawing/2014/main" id="{B8983C75-F54B-4A3D-9166-DB3B06503F6B}"/>
               </a:ext>
             </a:extLst>
           </p:cNvPr>
@@ -5077,7 +5077,7 @@
           <p:cNvPr id="5" name="Express on Render">
             <a:extLst xmlns:a="http://schemas.openxmlformats.org/drawingml/2006/main">
               <a:ext uri="{FF2B5EF4-FFF2-40B4-BE49-F238E27FC236}">
-                <a16:creationId xmlns:a16="http://schemas.microsoft.com/office/drawing/2014/main" id="{ED45F740-5AB6-4075-9328-2D04F1EEE745}"/>
+                <a16:creationId xmlns:a16="http://schemas.microsoft.com/office/drawing/2014/main" id="{BBF81FBE-C676-4ED3-9FE9-38068F824819}"/>
               </a:ext>
             </a:extLst>
           </p:cNvPr>
@@ -5147,7 +5147,7 @@
           <p:cNvPr id="8" name="HTTP workflow runner">
             <a:extLst xmlns:a="http://schemas.openxmlformats.org/drawingml/2006/main">
               <a:ext uri="{FF2B5EF4-FFF2-40B4-BE49-F238E27FC236}">
-                <a16:creationId xmlns:a16="http://schemas.microsoft.com/office/drawing/2014/main" id="{9254C635-3770-47A7-99A4-558631710000}"/>
+                <a16:creationId xmlns:a16="http://schemas.microsoft.com/office/drawing/2014/main" id="{9AD13A49-F98C-487F-8145-A477F56D8F44}"/>
               </a:ext>
             </a:extLst>
           </p:cNvPr>
@@ -5217,7 +5217,7 @@
           <p:cNvPr id="10" name="Owned shop sandbox">
             <a:extLst xmlns:a="http://schemas.openxmlformats.org/drawingml/2006/main">
               <a:ext uri="{FF2B5EF4-FFF2-40B4-BE49-F238E27FC236}">
-                <a16:creationId xmlns:a16="http://schemas.microsoft.com/office/drawing/2014/main" id="{9B2E0146-95F8-45E4-9127-5E5ABDD139DA}"/>
+                <a16:creationId xmlns:a16="http://schemas.microsoft.com/office/drawing/2014/main" id="{E7F67003-D97F-4A20-9563-62FFB954B90D}"/>
               </a:ext>
             </a:extLst>
           </p:cNvPr>
@@ -5287,7 +5287,7 @@
           <p:cNvPr id="12" name="Rules and fingerprints">
             <a:extLst xmlns:a="http://schemas.openxmlformats.org/drawingml/2006/main">
               <a:ext uri="{FF2B5EF4-FFF2-40B4-BE49-F238E27FC236}">
-                <a16:creationId xmlns:a16="http://schemas.microsoft.com/office/drawing/2014/main" id="{799BD8D5-623E-4894-B77F-B50A4913B2E4}"/>
+                <a16:creationId xmlns:a16="http://schemas.microsoft.com/office/drawing/2014/main" id="{588D5E51-B582-454C-BDE5-F186C557FDD9}"/>
               </a:ext>
             </a:extLst>
           </p:cNvPr>
@@ -5357,7 +5357,7 @@
           <p:cNvPr id="14" name="SQLite evidence history">
             <a:extLst xmlns:a="http://schemas.openxmlformats.org/drawingml/2006/main">
               <a:ext uri="{FF2B5EF4-FFF2-40B4-BE49-F238E27FC236}">
-                <a16:creationId xmlns:a16="http://schemas.microsoft.com/office/drawing/2014/main" id="{01F5ED93-7881-40E8-B02E-DBF62F7DAEF1}"/>
+                <a16:creationId xmlns:a16="http://schemas.microsoft.com/office/drawing/2014/main" id="{1ACFD432-E40C-4B58-9016-96FA6C3CF2C9}"/>
               </a:ext>
             </a:extLst>
           </p:cNvPr>
@@ -5427,7 +5427,7 @@
           <p:cNvPr id="16" name="Approved worker resume">
             <a:extLst xmlns:a="http://schemas.openxmlformats.org/drawingml/2006/main">
               <a:ext uri="{FF2B5EF4-FFF2-40B4-BE49-F238E27FC236}">
-                <a16:creationId xmlns:a16="http://schemas.microsoft.com/office/drawing/2014/main" id="{955E81EC-D60C-4918-A763-70E21FC99357}"/>
+                <a16:creationId xmlns:a16="http://schemas.microsoft.com/office/drawing/2014/main" id="{4D6F9DBC-42A0-4665-B276-8330495E25C8}"/>
               </a:ext>
             </a:extLst>
           </p:cNvPr>
@@ -5497,7 +5497,7 @@
           <p:cNvPr id="19" name="Shared TypeScript contracts">
             <a:extLst xmlns:a="http://schemas.openxmlformats.org/drawingml/2006/main">
               <a:ext uri="{FF2B5EF4-FFF2-40B4-BE49-F238E27FC236}">
-                <a16:creationId xmlns:a16="http://schemas.microsoft.com/office/drawing/2014/main" id="{4E77903A-B55B-4464-9CB1-12F827CE988C}"/>
+                <a16:creationId xmlns:a16="http://schemas.microsoft.com/office/drawing/2014/main" id="{5EFCDDC2-1AD7-4FDC-B7A4-06525A797D2C}"/>
               </a:ext>
             </a:extLst>
           </p:cNvPr>
@@ -5565,7 +5565,7 @@
           <p:cNvPr id="20" name="Temporary hosted history&#10;Local offline fallback">
             <a:extLst xmlns:a="http://schemas.openxmlformats.org/drawingml/2006/main">
               <a:ext uri="{FF2B5EF4-FFF2-40B4-BE49-F238E27FC236}">
-                <a16:creationId xmlns:a16="http://schemas.microsoft.com/office/drawing/2014/main" id="{CA88C3AC-A4C5-4262-94AD-D02C36D4CEA4}"/>
+                <a16:creationId xmlns:a16="http://schemas.microsoft.com/office/drawing/2014/main" id="{CD629E42-29FF-493D-8491-808EAFB30947}"/>
               </a:ext>
             </a:extLst>
           </p:cNvPr>
@@ -5654,7 +5654,7 @@
     </p:spTree>
     <p:extLst>
       <p:ext uri="{BB962C8B-B14F-4D97-AF65-F5344CB8AC3E}">
-        <p14:creationId xmlns:p14="http://schemas.microsoft.com/office/powerpoint/2010/main" val="1065600924"/>
+        <p14:creationId xmlns:p14="http://schemas.microsoft.com/office/powerpoint/2010/main" val="1799598821"/>
       </p:ext>
     </p:extLst>
   </p:cSld>
@@ -5685,7 +5685,7 @@
           <p:cNvPr id="6" name="Failure investigation and verified recovery">
             <a:extLst xmlns:a="http://schemas.openxmlformats.org/drawingml/2006/main">
               <a:ext uri="{FF2B5EF4-FFF2-40B4-BE49-F238E27FC236}">
-                <a16:creationId xmlns:a16="http://schemas.microsoft.com/office/drawing/2014/main" id="{4E14F80F-FD09-4D75-A7F6-A035F07040B0}"/>
+                <a16:creationId xmlns:a16="http://schemas.microsoft.com/office/drawing/2014/main" id="{74B31F50-31EA-49C4-BD01-8B31C82A57B4}"/>
               </a:ext>
             </a:extLst>
           </p:cNvPr>
@@ -5753,7 +5753,7 @@
           <p:cNvPr id="2" name="BizPlus AI     5/7">
             <a:extLst xmlns:a="http://schemas.openxmlformats.org/drawingml/2006/main">
               <a:ext uri="{FF2B5EF4-FFF2-40B4-BE49-F238E27FC236}">
-                <a16:creationId xmlns:a16="http://schemas.microsoft.com/office/drawing/2014/main" id="{FBB30F99-FC37-4FC0-A25B-9B1FD08A5ABC}"/>
+                <a16:creationId xmlns:a16="http://schemas.microsoft.com/office/drawing/2014/main" id="{BF281953-1721-428B-B22C-A4446C0E714D}"/>
               </a:ext>
             </a:extLst>
           </p:cNvPr>
@@ -5821,7 +5821,7 @@
           <p:cNvPr id="3" name="1  Run Missing confirmation&#10;&#10;2  Inspect response and logs&#10;&#10;3  Approve ">
             <a:extLst xmlns:a="http://schemas.openxmlformats.org/drawingml/2006/main">
               <a:ext uri="{FF2B5EF4-FFF2-40B4-BE49-F238E27FC236}">
-                <a16:creationId xmlns:a16="http://schemas.microsoft.com/office/drawing/2014/main" id="{C1D8586C-DC94-4D0C-AE07-AEC0D0DA9A1C}"/>
+                <a16:creationId xmlns:a16="http://schemas.microsoft.com/office/drawing/2014/main" id="{E57FD8F6-CD8A-4134-B8D5-4F1813709678}"/>
               </a:ext>
             </a:extLst>
           </p:cNvPr>
@@ -5973,7 +5973,7 @@
           <p:cNvPr id="4" name="">
             <a:extLst xmlns:a="http://schemas.openxmlformats.org/drawingml/2006/main">
               <a:ext uri="{FF2B5EF4-FFF2-40B4-BE49-F238E27FC236}">
-                <a16:creationId xmlns:a16="http://schemas.microsoft.com/office/drawing/2014/main" id="{EB81E796-4380-4405-8DD8-0331474CD5B1}"/>
+                <a16:creationId xmlns:a16="http://schemas.microsoft.com/office/drawing/2014/main" id="{2DAE4BC0-35A8-41BE-BC30-A5394B718478}"/>
               </a:ext>
             </a:extLst>
           </p:cNvPr>
@@ -5983,7 +5983,7 @@
           <p:nvPr/>
         </p:nvPicPr>
         <p:blipFill>
-          <a:blip xmlns:r="http://schemas.openxmlformats.org/officeDocument/2006/relationships" xmlns:a="http://schemas.openxmlformats.org/drawingml/2006/main" r:embed="Ra29d37220bcd4003"/>
+          <a:blip xmlns:r="http://schemas.openxmlformats.org/officeDocument/2006/relationships" xmlns:a="http://schemas.openxmlformats.org/drawingml/2006/main" r:embed="Rc3bd1cb469724cfa"/>
           <a:srcRect xmlns:a="http://schemas.openxmlformats.org/drawingml/2006/main" l="18300" t="33700" r="3500" b="0"/>
           <a:stretch xmlns:a="http://schemas.openxmlformats.org/drawingml/2006/main"/>
         </p:blipFill>
@@ -6002,7 +6002,7 @@
           <p:cNvPr id="5" name="1 payment before recovery     1 payment after recovery">
             <a:extLst xmlns:a="http://schemas.openxmlformats.org/drawingml/2006/main">
               <a:ext uri="{FF2B5EF4-FFF2-40B4-BE49-F238E27FC236}">
-                <a16:creationId xmlns:a16="http://schemas.microsoft.com/office/drawing/2014/main" id="{5E9C0012-B4E1-42C7-9367-F5B49914104C}"/>
+                <a16:creationId xmlns:a16="http://schemas.microsoft.com/office/drawing/2014/main" id="{6C0CCF7B-A895-4D89-B78C-806D6A95C2E6}"/>
               </a:ext>
             </a:extLst>
           </p:cNvPr>
@@ -6068,7 +6068,7 @@
     </p:spTree>
     <p:extLst>
       <p:ext uri="{BB962C8B-B14F-4D97-AF65-F5344CB8AC3E}">
-        <p14:creationId xmlns:p14="http://schemas.microsoft.com/office/powerpoint/2010/main" val="1922986533"/>
+        <p14:creationId xmlns:p14="http://schemas.microsoft.com/office/powerpoint/2010/main" val="246266806"/>
       </p:ext>
     </p:extLst>
   </p:cSld>
@@ -6099,7 +6099,7 @@
           <p:cNvPr id="7" name="Measured sandbox results">
             <a:extLst xmlns:a="http://schemas.openxmlformats.org/drawingml/2006/main">
               <a:ext uri="{FF2B5EF4-FFF2-40B4-BE49-F238E27FC236}">
-                <a16:creationId xmlns:a16="http://schemas.microsoft.com/office/drawing/2014/main" id="{3BE5FD45-DF00-4ABB-9BFB-36415DFCB950}"/>
+                <a16:creationId xmlns:a16="http://schemas.microsoft.com/office/drawing/2014/main" id="{7C4F8E21-4CAA-42E4-8E15-D292F61A1E0A}"/>
               </a:ext>
             </a:extLst>
           </p:cNvPr>
@@ -6167,7 +6167,7 @@
           <p:cNvPr id="2" name="BizPlus AI     6/7">
             <a:extLst xmlns:a="http://schemas.openxmlformats.org/drawingml/2006/main">
               <a:ext uri="{FF2B5EF4-FFF2-40B4-BE49-F238E27FC236}">
-                <a16:creationId xmlns:a16="http://schemas.microsoft.com/office/drawing/2014/main" id="{2C186A3E-AE14-4698-914F-3BD5C1517F77}"/>
+                <a16:creationId xmlns:a16="http://schemas.microsoft.com/office/drawing/2014/main" id="{28303E56-2541-400B-8EDA-597868E9BA16}"/>
               </a:ext>
             </a:extLst>
           </p:cNvPr>
@@ -6235,7 +6235,7 @@
           <p:cNvPr id="3" name="">
             <a:extLst xmlns:a="http://schemas.openxmlformats.org/drawingml/2006/main">
               <a:ext uri="{FF2B5EF4-FFF2-40B4-BE49-F238E27FC236}">
-                <a16:creationId xmlns:a16="http://schemas.microsoft.com/office/drawing/2014/main" id="{E8379896-5E52-4C7D-947B-D27A384B33E3}"/>
+                <a16:creationId xmlns:a16="http://schemas.microsoft.com/office/drawing/2014/main" id="{4A650798-D8E7-46BD-B198-5F51B2D14C4D}"/>
               </a:ext>
             </a:extLst>
           </p:cNvPr>
@@ -6755,7 +6755,7 @@
           <p:cNvPr id="4" name="Focused demonstration">
             <a:extLst xmlns:a="http://schemas.openxmlformats.org/drawingml/2006/main">
               <a:ext uri="{FF2B5EF4-FFF2-40B4-BE49-F238E27FC236}">
-                <a16:creationId xmlns:a16="http://schemas.microsoft.com/office/drawing/2014/main" id="{D21A41B7-5C57-439A-95F0-8863DD7CCE17}"/>
+                <a16:creationId xmlns:a16="http://schemas.microsoft.com/office/drawing/2014/main" id="{F0860603-990A-4E19-8F09-EB7D4D3E3F9B}"/>
               </a:ext>
             </a:extLst>
           </p:cNvPr>
@@ -6823,7 +6823,7 @@
           <p:cNvPr id="5" name="Missing business outcome&#10;&#10;Evidence linked to rules&#10;&#10;Approval with veri">
             <a:extLst xmlns:a="http://schemas.openxmlformats.org/drawingml/2006/main">
               <a:ext uri="{FF2B5EF4-FFF2-40B4-BE49-F238E27FC236}">
-                <a16:creationId xmlns:a16="http://schemas.microsoft.com/office/drawing/2014/main" id="{348FCF2C-F74E-4DBE-831E-5E80F613FB6D}"/>
+                <a16:creationId xmlns:a16="http://schemas.microsoft.com/office/drawing/2014/main" id="{E671733C-4874-4AAA-A4F8-1650BDD08687}"/>
               </a:ext>
             </a:extLst>
           </p:cNvPr>
@@ -6947,7 +6947,7 @@
           <p:cNvPr id="6" name="Timings include the sandbox’s 220 ms request delay.&#10;Existing tools off">
             <a:extLst xmlns:a="http://schemas.openxmlformats.org/drawingml/2006/main">
               <a:ext uri="{FF2B5EF4-FFF2-40B4-BE49-F238E27FC236}">
-                <a16:creationId xmlns:a16="http://schemas.microsoft.com/office/drawing/2014/main" id="{027B3AB9-10FC-4916-8CCC-DDE32BD2C41A}"/>
+                <a16:creationId xmlns:a16="http://schemas.microsoft.com/office/drawing/2014/main" id="{72BDB379-DAF1-4C7C-BA49-0D8F158EA6BE}"/>
               </a:ext>
             </a:extLst>
           </p:cNvPr>
@@ -7059,7 +7059,7 @@
     </p:spTree>
     <p:extLst>
       <p:ext uri="{BB962C8B-B14F-4D97-AF65-F5344CB8AC3E}">
-        <p14:creationId xmlns:p14="http://schemas.microsoft.com/office/powerpoint/2010/main" val="686444491"/>
+        <p14:creationId xmlns:p14="http://schemas.microsoft.com/office/powerpoint/2010/main" val="846429614"/>
       </p:ext>
     </p:extLst>
   </p:cSld>
@@ -7090,7 +7090,7 @@
           <p:cNvPr id="7" name="Release and roadmap">
             <a:extLst xmlns:a="http://schemas.openxmlformats.org/drawingml/2006/main">
               <a:ext uri="{FF2B5EF4-FFF2-40B4-BE49-F238E27FC236}">
-                <a16:creationId xmlns:a16="http://schemas.microsoft.com/office/drawing/2014/main" id="{E914BD48-CE95-475F-9704-ACB8B58785CD}"/>
+                <a16:creationId xmlns:a16="http://schemas.microsoft.com/office/drawing/2014/main" id="{A8530F0D-BD98-4708-87E2-4034FCE44731}"/>
               </a:ext>
             </a:extLst>
           </p:cNvPr>
@@ -7158,7 +7158,7 @@
           <p:cNvPr id="2" name="BizPlus AI     7/7">
             <a:extLst xmlns:a="http://schemas.openxmlformats.org/drawingml/2006/main">
               <a:ext uri="{FF2B5EF4-FFF2-40B4-BE49-F238E27FC236}">
-                <a16:creationId xmlns:a16="http://schemas.microsoft.com/office/drawing/2014/main" id="{CAEF58F4-D1D8-4AD6-8E87-2D0BA8D8E315}"/>
+                <a16:creationId xmlns:a16="http://schemas.microsoft.com/office/drawing/2014/main" id="{646BDE58-5D2E-4CCF-B39D-C40095519F42}"/>
               </a:ext>
             </a:extLst>
           </p:cNvPr>
@@ -7226,7 +7226,7 @@
           <p:cNvPr id="3" name="">
             <a:extLst xmlns:a="http://schemas.openxmlformats.org/drawingml/2006/main">
               <a:ext uri="{FF2B5EF4-FFF2-40B4-BE49-F238E27FC236}">
-                <a16:creationId xmlns:a16="http://schemas.microsoft.com/office/drawing/2014/main" id="{8D3893E0-356A-4C4E-9D89-DB54C38A160C}"/>
+                <a16:creationId xmlns:a16="http://schemas.microsoft.com/office/drawing/2014/main" id="{9CA1A27F-8D3D-4CE4-86F8-FD91930662E3}"/>
               </a:ext>
             </a:extLst>
           </p:cNvPr>
@@ -7663,10 +7663,10 @@
       </p:graphicFrame>
       <p:sp>
         <p:nvSpPr>
-          <p:cNvPr id="4" name="Deployment handoff">
+          <p:cNvPr id="4" name="Live backend health">
             <a:extLst xmlns:a="http://schemas.openxmlformats.org/drawingml/2006/main">
               <a:ext uri="{FF2B5EF4-FFF2-40B4-BE49-F238E27FC236}">
-                <a16:creationId xmlns:a16="http://schemas.microsoft.com/office/drawing/2014/main" id="{0460776E-CB09-4C95-9EE5-714E8C3CE704}"/>
+                <a16:creationId xmlns:a16="http://schemas.microsoft.com/office/drawing/2014/main" id="{A0756F22-F8D9-4DA3-AA2F-DDB66ACE24F5}"/>
               </a:ext>
             </a:extLst>
           </p:cNvPr>
@@ -7724,17 +7724,17 @@
                 <a:ea typeface="Arial"/>
                 <a:cs typeface="Arial"/>
               </a:rPr>
-              <a:t>Deployment handoff</a:t>
+              <a:t>Live backend health</a:t>
             </a:r>
           </a:p>
         </p:txBody>
       </p:sp>
       <p:sp>
         <p:nvSpPr>
-          <p:cNvPr id="5" name="Netlify frontend and Render backend configuration included">
+          <p:cNvPr id="5" name="https://bizplus-ai-api.onrender.com/health">
             <a:extLst xmlns:a="http://schemas.openxmlformats.org/drawingml/2006/main">
               <a:ext uri="{FF2B5EF4-FFF2-40B4-BE49-F238E27FC236}">
-                <a16:creationId xmlns:a16="http://schemas.microsoft.com/office/drawing/2014/main" id="{203D8E3B-7977-4FCE-B65E-8FD626C138B9}"/>
+                <a16:creationId xmlns:a16="http://schemas.microsoft.com/office/drawing/2014/main" id="{4458D4C0-D7AE-4250-87EB-BF475DDF061C}"/>
               </a:ext>
             </a:extLst>
           </p:cNvPr>
@@ -7791,18 +7791,19 @@
                 <a:latin typeface="Arial"/>
                 <a:ea typeface="Arial"/>
                 <a:cs typeface="Arial"/>
+                <a:hlinkClick xmlns:r="http://schemas.openxmlformats.org/officeDocument/2006/relationships" r:id="R2a084b31efd04979"/>
               </a:rPr>
-              <a:t>Netlify frontend and Render backend configuration included</a:t>
+              <a:t>https://bizplus-ai-api.onrender.com/health</a:t>
             </a:r>
           </a:p>
         </p:txBody>
       </p:sp>
       <p:sp>
         <p:nvSpPr>
-          <p:cNvPr id="6" name="Local API and browser journey verified. Public deployment and cold-sta">
+          <p:cNvPr id="6" name="18/18 hosted API checks passed. Public dashboard, cold-start and secon">
             <a:extLst xmlns:a="http://schemas.openxmlformats.org/drawingml/2006/main">
               <a:ext uri="{FF2B5EF4-FFF2-40B4-BE49-F238E27FC236}">
-                <a16:creationId xmlns:a16="http://schemas.microsoft.com/office/drawing/2014/main" id="{E73BD338-922F-46DA-B76E-F4C8E9D37FAC}"/>
+                <a16:creationId xmlns:a16="http://schemas.microsoft.com/office/drawing/2014/main" id="{13CE37D5-8230-423B-A65B-A11C9CB37F65}"/>
               </a:ext>
             </a:extLst>
           </p:cNvPr>
@@ -7860,7 +7861,7 @@
                 <a:ea typeface="Arial"/>
                 <a:cs typeface="Arial"/>
               </a:rPr>
-              <a:t>Local API and browser journey verified. Public deployment and cold-start checks remain pending.</a:t>
+              <a:t>18/18 hosted API checks passed. Public dashboard, cold-start and second-device checks pending.</a:t>
             </a:r>
           </a:p>
         </p:txBody>
@@ -7868,7 +7869,7 @@
     </p:spTree>
     <p:extLst>
       <p:ext uri="{BB962C8B-B14F-4D97-AF65-F5344CB8AC3E}">
-        <p14:creationId xmlns:p14="http://schemas.microsoft.com/office/powerpoint/2010/main" val="910956760"/>
+        <p14:creationId xmlns:p14="http://schemas.microsoft.com/office/powerpoint/2010/main" val="205517409"/>
       </p:ext>
     </p:extLst>
   </p:cSld>

</xml_diff>